<commit_message>
Update capture screen in slide
</commit_message>
<xml_diff>
--- a/docs/presentation.pptx
+++ b/docs/presentation.pptx
@@ -1778,7 +1778,7 @@
           <a:p>
             <a:fld id="{5BCAD085-E8A6-8845-BD4E-CB4CCA059FC4}" type="datetimeFigureOut">
               <a:rPr lang="en-US" smtClean="0"/>
-              <a:t>4/23/26</a:t>
+              <a:t>4/24/26</a:t>
             </a:fld>
             <a:endParaRPr lang="en-US"/>
           </a:p>
@@ -1946,7 +1946,7 @@
           <a:p>
             <a:fld id="{5BCAD085-E8A6-8845-BD4E-CB4CCA059FC4}" type="datetimeFigureOut">
               <a:rPr lang="en-US" smtClean="0"/>
-              <a:t>4/23/26</a:t>
+              <a:t>4/24/26</a:t>
             </a:fld>
             <a:endParaRPr lang="en-US"/>
           </a:p>
@@ -2124,7 +2124,7 @@
           <a:p>
             <a:fld id="{5BCAD085-E8A6-8845-BD4E-CB4CCA059FC4}" type="datetimeFigureOut">
               <a:rPr lang="en-US" smtClean="0"/>
-              <a:t>4/23/26</a:t>
+              <a:t>4/24/26</a:t>
             </a:fld>
             <a:endParaRPr lang="en-US"/>
           </a:p>
@@ -2292,7 +2292,7 @@
           <a:p>
             <a:fld id="{5BCAD085-E8A6-8845-BD4E-CB4CCA059FC4}" type="datetimeFigureOut">
               <a:rPr lang="en-US" smtClean="0"/>
-              <a:t>4/23/26</a:t>
+              <a:t>4/24/26</a:t>
             </a:fld>
             <a:endParaRPr lang="en-US"/>
           </a:p>
@@ -2537,7 +2537,7 @@
           <a:p>
             <a:fld id="{5BCAD085-E8A6-8845-BD4E-CB4CCA059FC4}" type="datetimeFigureOut">
               <a:rPr lang="en-US" smtClean="0"/>
-              <a:t>4/23/26</a:t>
+              <a:t>4/24/26</a:t>
             </a:fld>
             <a:endParaRPr lang="en-US"/>
           </a:p>
@@ -2822,7 +2822,7 @@
           <a:p>
             <a:fld id="{5BCAD085-E8A6-8845-BD4E-CB4CCA059FC4}" type="datetimeFigureOut">
               <a:rPr lang="en-US" smtClean="0"/>
-              <a:t>4/23/26</a:t>
+              <a:t>4/24/26</a:t>
             </a:fld>
             <a:endParaRPr lang="en-US"/>
           </a:p>
@@ -3241,7 +3241,7 @@
           <a:p>
             <a:fld id="{5BCAD085-E8A6-8845-BD4E-CB4CCA059FC4}" type="datetimeFigureOut">
               <a:rPr lang="en-US" smtClean="0"/>
-              <a:t>4/23/26</a:t>
+              <a:t>4/24/26</a:t>
             </a:fld>
             <a:endParaRPr lang="en-US"/>
           </a:p>
@@ -3358,7 +3358,7 @@
           <a:p>
             <a:fld id="{5BCAD085-E8A6-8845-BD4E-CB4CCA059FC4}" type="datetimeFigureOut">
               <a:rPr lang="en-US" smtClean="0"/>
-              <a:t>4/23/26</a:t>
+              <a:t>4/24/26</a:t>
             </a:fld>
             <a:endParaRPr lang="en-US"/>
           </a:p>
@@ -3453,7 +3453,7 @@
           <a:p>
             <a:fld id="{5BCAD085-E8A6-8845-BD4E-CB4CCA059FC4}" type="datetimeFigureOut">
               <a:rPr lang="en-US" smtClean="0"/>
-              <a:t>4/23/26</a:t>
+              <a:t>4/24/26</a:t>
             </a:fld>
             <a:endParaRPr lang="en-US"/>
           </a:p>
@@ -3728,7 +3728,7 @@
           <a:p>
             <a:fld id="{5BCAD085-E8A6-8845-BD4E-CB4CCA059FC4}" type="datetimeFigureOut">
               <a:rPr lang="en-US" smtClean="0"/>
-              <a:t>4/23/26</a:t>
+              <a:t>4/24/26</a:t>
             </a:fld>
             <a:endParaRPr lang="en-US"/>
           </a:p>
@@ -3980,7 +3980,7 @@
           <a:p>
             <a:fld id="{5BCAD085-E8A6-8845-BD4E-CB4CCA059FC4}" type="datetimeFigureOut">
               <a:rPr lang="en-US" smtClean="0"/>
-              <a:t>4/23/26</a:t>
+              <a:t>4/24/26</a:t>
             </a:fld>
             <a:endParaRPr lang="en-US"/>
           </a:p>
@@ -4191,7 +4191,7 @@
           <a:p>
             <a:fld id="{5BCAD085-E8A6-8845-BD4E-CB4CCA059FC4}" type="datetimeFigureOut">
               <a:rPr lang="en-US" smtClean="0"/>
-              <a:t>4/23/26</a:t>
+              <a:t>4/24/26</a:t>
             </a:fld>
             <a:endParaRPr lang="en-US"/>
           </a:p>
@@ -18606,6 +18606,62 @@
       </p:grpSpPr>
       <p:sp>
         <p:nvSpPr>
+          <p:cNvPr id="9" name="Rectangle 8">
+            <a:extLst>
+              <a:ext uri="{FF2B5EF4-FFF2-40B4-BE49-F238E27FC236}">
+                <a16:creationId xmlns:a16="http://schemas.microsoft.com/office/drawing/2014/main" id="{3A0E5505-EB02-384B-D9F1-F134231FB2D7}"/>
+              </a:ext>
+            </a:extLst>
+          </p:cNvPr>
+          <p:cNvSpPr/>
+          <p:nvPr/>
+        </p:nvSpPr>
+        <p:spPr>
+          <a:xfrm>
+            <a:off x="5838940" y="76200"/>
+            <a:ext cx="6349885" cy="6781800"/>
+          </a:xfrm>
+          <a:prstGeom prst="rect">
+            <a:avLst/>
+          </a:prstGeom>
+          <a:solidFill>
+            <a:schemeClr val="bg1"/>
+          </a:solidFill>
+          <a:ln>
+            <a:solidFill>
+              <a:schemeClr val="bg1"/>
+            </a:solidFill>
+          </a:ln>
+        </p:spPr>
+        <p:style>
+          <a:lnRef idx="1">
+            <a:schemeClr val="accent1"/>
+          </a:lnRef>
+          <a:fillRef idx="3">
+            <a:schemeClr val="accent1"/>
+          </a:fillRef>
+          <a:effectRef idx="2">
+            <a:schemeClr val="accent1"/>
+          </a:effectRef>
+          <a:fontRef idx="minor">
+            <a:schemeClr val="lt1"/>
+          </a:fontRef>
+        </p:style>
+        <p:txBody>
+          <a:bodyPr rtlCol="0" anchor="ctr"/>
+          <a:lstStyle/>
+          <a:p>
+            <a:pPr algn="ctr"/>
+            <a:r>
+              <a:rPr lang="en-US" dirty="0"/>
+              <a:t>screencapture-localhost-3000-2026-04-24-08_42_40.png</a:t>
+            </a:r>
+            <a:endParaRPr lang="en-TH" dirty="0"/>
+          </a:p>
+        </p:txBody>
+      </p:sp>
+      <p:sp>
+        <p:nvSpPr>
           <p:cNvPr id="2" name="Rectangle 1"/>
           <p:cNvSpPr/>
           <p:nvPr/>
@@ -18844,132 +18900,36 @@
           </a:p>
         </p:txBody>
       </p:sp>
-      <p:sp>
-        <p:nvSpPr>
-          <p:cNvPr id="6" name="Rectangle 5"/>
-          <p:cNvSpPr/>
-          <p:nvPr/>
-        </p:nvSpPr>
-        <p:spPr>
-          <a:xfrm>
-            <a:off x="7589520" y="1005840"/>
-            <a:ext cx="3200400" cy="5394960"/>
-          </a:xfrm>
-          <a:prstGeom prst="rect">
-            <a:avLst/>
-          </a:prstGeom>
-          <a:solidFill>
-            <a:srgbClr val="0D1B2A"/>
-          </a:solidFill>
-          <a:ln w="31750">
-            <a:solidFill>
-              <a:srgbClr val="4F9CF9"/>
-            </a:solidFill>
-          </a:ln>
-        </p:spPr>
-        <p:style>
-          <a:lnRef idx="1">
-            <a:schemeClr val="accent1"/>
-          </a:lnRef>
-          <a:fillRef idx="3">
-            <a:schemeClr val="accent1"/>
-          </a:fillRef>
-          <a:effectRef idx="2">
-            <a:schemeClr val="accent1"/>
-          </a:effectRef>
-          <a:fontRef idx="minor">
-            <a:schemeClr val="lt1"/>
-          </a:fontRef>
-        </p:style>
-        <p:txBody>
-          <a:bodyPr rtlCol="0" anchor="ctr"/>
-          <a:lstStyle/>
-          <a:p>
-            <a:pPr algn="ctr"/>
-            <a:endParaRPr/>
-          </a:p>
-        </p:txBody>
-      </p:sp>
-      <p:sp>
-        <p:nvSpPr>
-          <p:cNvPr id="7" name="Oval 6"/>
-          <p:cNvSpPr/>
-          <p:nvPr/>
-        </p:nvSpPr>
-        <p:spPr>
-          <a:xfrm>
-            <a:off x="8686800" y="1097280"/>
-            <a:ext cx="1005840" cy="228600"/>
-          </a:xfrm>
-          <a:prstGeom prst="ellipse">
-            <a:avLst/>
-          </a:prstGeom>
-          <a:solidFill>
-            <a:srgbClr val="4F9CF9"/>
-          </a:solidFill>
-          <a:ln>
-            <a:noFill/>
-          </a:ln>
-        </p:spPr>
-        <p:style>
-          <a:lnRef idx="1">
-            <a:schemeClr val="accent1"/>
-          </a:lnRef>
-          <a:fillRef idx="3">
-            <a:schemeClr val="accent1"/>
-          </a:fillRef>
-          <a:effectRef idx="2">
-            <a:schemeClr val="accent1"/>
-          </a:effectRef>
-          <a:fontRef idx="minor">
-            <a:schemeClr val="lt1"/>
-          </a:fontRef>
-        </p:style>
-        <p:txBody>
-          <a:bodyPr rtlCol="0" anchor="ctr"/>
-          <a:lstStyle/>
-          <a:p>
-            <a:pPr algn="ctr"/>
-            <a:endParaRPr/>
-          </a:p>
-        </p:txBody>
-      </p:sp>
-      <p:sp>
-        <p:nvSpPr>
-          <p:cNvPr id="8" name="TextBox 7"/>
-          <p:cNvSpPr txBox="1"/>
-          <p:nvPr/>
-        </p:nvSpPr>
-        <p:spPr>
-          <a:xfrm>
-            <a:off x="7680960" y="3017520"/>
-            <a:ext cx="3017520" cy="1280160"/>
-          </a:xfrm>
-          <a:prstGeom prst="rect">
-            <a:avLst/>
-          </a:prstGeom>
-          <a:noFill/>
-        </p:spPr>
-        <p:txBody>
-          <a:bodyPr wrap="square">
-            <a:spAutoFit/>
-          </a:bodyPr>
-          <a:lstStyle/>
-          <a:p>
-            <a:pPr algn="ctr"/>
-            <a:r>
-              <a:rPr sz="1400" b="0">
-                <a:solidFill>
-                  <a:srgbClr val="7A9CC4"/>
-                </a:solidFill>
-              </a:rPr>
-              <a:t>📱
-วางภาพ screenshot
-ที่นี่</a:t>
-            </a:r>
-          </a:p>
-        </p:txBody>
-      </p:sp>
+      <p:pic>
+        <p:nvPicPr>
+          <p:cNvPr id="11" name="Picture 10">
+            <a:extLst>
+              <a:ext uri="{FF2B5EF4-FFF2-40B4-BE49-F238E27FC236}">
+                <a16:creationId xmlns:a16="http://schemas.microsoft.com/office/drawing/2014/main" id="{E7CD3C54-C86D-5BDB-08AD-9BAB2F440313}"/>
+              </a:ext>
+            </a:extLst>
+          </p:cNvPr>
+          <p:cNvPicPr>
+            <a:picLocks noChangeAspect="1"/>
+          </p:cNvPicPr>
+          <p:nvPr/>
+        </p:nvPicPr>
+        <p:blipFill>
+          <a:blip r:embed="rId3"/>
+          <a:stretch>
+            <a:fillRect/>
+          </a:stretch>
+        </p:blipFill>
+        <p:spPr>
+          <a:xfrm>
+            <a:off x="7789694" y="208953"/>
+            <a:ext cx="2448375" cy="6511887"/>
+          </a:xfrm>
+          <a:prstGeom prst="rect">
+            <a:avLst/>
+          </a:prstGeom>
+        </p:spPr>
+      </p:pic>
     </p:spTree>
   </p:cSld>
   <p:clrMapOvr>
@@ -19245,24 +19205,30 @@
       </p:sp>
       <p:sp>
         <p:nvSpPr>
-          <p:cNvPr id="6" name="Rectangle 5"/>
+          <p:cNvPr id="9" name="Rectangle 8">
+            <a:extLst>
+              <a:ext uri="{FF2B5EF4-FFF2-40B4-BE49-F238E27FC236}">
+                <a16:creationId xmlns:a16="http://schemas.microsoft.com/office/drawing/2014/main" id="{1647D6B4-D2F9-FC21-BAC7-415BA2429BA5}"/>
+              </a:ext>
+            </a:extLst>
+          </p:cNvPr>
           <p:cNvSpPr/>
           <p:nvPr/>
         </p:nvSpPr>
         <p:spPr>
           <a:xfrm>
-            <a:off x="7589520" y="1005840"/>
-            <a:ext cx="3200400" cy="5394960"/>
+            <a:off x="5838940" y="76200"/>
+            <a:ext cx="6349885" cy="6781800"/>
           </a:xfrm>
           <a:prstGeom prst="rect">
             <a:avLst/>
           </a:prstGeom>
           <a:solidFill>
-            <a:srgbClr val="0D1B2A"/>
+            <a:schemeClr val="bg1"/>
           </a:solidFill>
-          <a:ln w="31750">
+          <a:ln>
             <a:solidFill>
-              <a:srgbClr val="4F9CF9"/>
+              <a:schemeClr val="bg1"/>
             </a:solidFill>
           </a:ln>
         </p:spPr>
@@ -19285,90 +19251,70 @@
           <a:lstStyle/>
           <a:p>
             <a:pPr algn="ctr"/>
-            <a:endParaRPr/>
-          </a:p>
-        </p:txBody>
-      </p:sp>
-      <p:sp>
-        <p:nvSpPr>
-          <p:cNvPr id="7" name="Oval 6"/>
-          <p:cNvSpPr/>
-          <p:nvPr/>
-        </p:nvSpPr>
-        <p:spPr>
-          <a:xfrm>
-            <a:off x="8686800" y="1097280"/>
-            <a:ext cx="1005840" cy="228600"/>
-          </a:xfrm>
-          <a:prstGeom prst="ellipse">
-            <a:avLst/>
-          </a:prstGeom>
-          <a:solidFill>
-            <a:srgbClr val="4F9CF9"/>
-          </a:solidFill>
-          <a:ln>
-            <a:noFill/>
-          </a:ln>
-        </p:spPr>
-        <p:style>
-          <a:lnRef idx="1">
-            <a:schemeClr val="accent1"/>
-          </a:lnRef>
-          <a:fillRef idx="3">
-            <a:schemeClr val="accent1"/>
-          </a:fillRef>
-          <a:effectRef idx="2">
-            <a:schemeClr val="accent1"/>
-          </a:effectRef>
-          <a:fontRef idx="minor">
-            <a:schemeClr val="lt1"/>
-          </a:fontRef>
-        </p:style>
-        <p:txBody>
-          <a:bodyPr rtlCol="0" anchor="ctr"/>
-          <a:lstStyle/>
-          <a:p>
-            <a:pPr algn="ctr"/>
-            <a:endParaRPr/>
-          </a:p>
-        </p:txBody>
-      </p:sp>
-      <p:sp>
-        <p:nvSpPr>
-          <p:cNvPr id="8" name="TextBox 7"/>
-          <p:cNvSpPr txBox="1"/>
-          <p:nvPr/>
-        </p:nvSpPr>
-        <p:spPr>
-          <a:xfrm>
-            <a:off x="7680960" y="3017520"/>
-            <a:ext cx="3017520" cy="1280160"/>
-          </a:xfrm>
-          <a:prstGeom prst="rect">
-            <a:avLst/>
-          </a:prstGeom>
-          <a:noFill/>
-        </p:spPr>
-        <p:txBody>
-          <a:bodyPr wrap="square">
-            <a:spAutoFit/>
-          </a:bodyPr>
-          <a:lstStyle/>
-          <a:p>
-            <a:pPr algn="ctr"/>
-            <a:r>
-              <a:rPr sz="1400" b="0">
-                <a:solidFill>
-                  <a:srgbClr val="7A9CC4"/>
-                </a:solidFill>
-              </a:rPr>
-              <a:t>📱
-วางภาพ screenshot
-ที่นี่</a:t>
-            </a:r>
-          </a:p>
-        </p:txBody>
-      </p:sp>
+            <a:endParaRPr lang="en-TH"/>
+          </a:p>
+        </p:txBody>
+      </p:sp>
+      <p:pic>
+        <p:nvPicPr>
+          <p:cNvPr id="11" name="Picture 10">
+            <a:extLst>
+              <a:ext uri="{FF2B5EF4-FFF2-40B4-BE49-F238E27FC236}">
+                <a16:creationId xmlns:a16="http://schemas.microsoft.com/office/drawing/2014/main" id="{0F865E31-E2B7-DF69-37B3-537581EA27BB}"/>
+              </a:ext>
+            </a:extLst>
+          </p:cNvPr>
+          <p:cNvPicPr>
+            <a:picLocks noChangeAspect="1"/>
+          </p:cNvPicPr>
+          <p:nvPr/>
+        </p:nvPicPr>
+        <p:blipFill>
+          <a:blip r:embed="rId3"/>
+          <a:stretch>
+            <a:fillRect/>
+          </a:stretch>
+        </p:blipFill>
+        <p:spPr>
+          <a:xfrm>
+            <a:off x="6438682" y="333805"/>
+            <a:ext cx="2085322" cy="6158429"/>
+          </a:xfrm>
+          <a:prstGeom prst="rect">
+            <a:avLst/>
+          </a:prstGeom>
+        </p:spPr>
+      </p:pic>
+      <p:pic>
+        <p:nvPicPr>
+          <p:cNvPr id="13" name="Picture 12">
+            <a:extLst>
+              <a:ext uri="{FF2B5EF4-FFF2-40B4-BE49-F238E27FC236}">
+                <a16:creationId xmlns:a16="http://schemas.microsoft.com/office/drawing/2014/main" id="{8D73F545-4E95-B4F7-2F13-6D56AAD71173}"/>
+              </a:ext>
+            </a:extLst>
+          </p:cNvPr>
+          <p:cNvPicPr>
+            <a:picLocks noChangeAspect="1"/>
+          </p:cNvPicPr>
+          <p:nvPr/>
+        </p:nvPicPr>
+        <p:blipFill>
+          <a:blip r:embed="rId4"/>
+          <a:stretch>
+            <a:fillRect/>
+          </a:stretch>
+        </p:blipFill>
+        <p:spPr>
+          <a:xfrm>
+            <a:off x="9431966" y="381739"/>
+            <a:ext cx="2085321" cy="6094521"/>
+          </a:xfrm>
+          <a:prstGeom prst="rect">
+            <a:avLst/>
+          </a:prstGeom>
+        </p:spPr>
+      </p:pic>
     </p:spTree>
   </p:cSld>
   <p:clrMapOvr>
@@ -19614,24 +19560,30 @@
       </p:sp>
       <p:sp>
         <p:nvSpPr>
-          <p:cNvPr id="6" name="Rectangle 5"/>
+          <p:cNvPr id="9" name="Rectangle 8">
+            <a:extLst>
+              <a:ext uri="{FF2B5EF4-FFF2-40B4-BE49-F238E27FC236}">
+                <a16:creationId xmlns:a16="http://schemas.microsoft.com/office/drawing/2014/main" id="{F94974CF-A249-6CC2-D280-87BAE8CBC9FC}"/>
+              </a:ext>
+            </a:extLst>
+          </p:cNvPr>
           <p:cNvSpPr/>
           <p:nvPr/>
         </p:nvSpPr>
         <p:spPr>
           <a:xfrm>
-            <a:off x="7589520" y="1005840"/>
-            <a:ext cx="3200400" cy="5394960"/>
+            <a:off x="5838940" y="76200"/>
+            <a:ext cx="6349885" cy="6781800"/>
           </a:xfrm>
           <a:prstGeom prst="rect">
             <a:avLst/>
           </a:prstGeom>
           <a:solidFill>
-            <a:srgbClr val="0D1B2A"/>
+            <a:schemeClr val="bg1"/>
           </a:solidFill>
-          <a:ln w="31750">
+          <a:ln>
             <a:solidFill>
-              <a:srgbClr val="4F9CF9"/>
+              <a:schemeClr val="bg1"/>
             </a:solidFill>
           </a:ln>
         </p:spPr>
@@ -19654,90 +19606,40 @@
           <a:lstStyle/>
           <a:p>
             <a:pPr algn="ctr"/>
-            <a:endParaRPr/>
-          </a:p>
-        </p:txBody>
-      </p:sp>
-      <p:sp>
-        <p:nvSpPr>
-          <p:cNvPr id="7" name="Oval 6"/>
-          <p:cNvSpPr/>
-          <p:nvPr/>
-        </p:nvSpPr>
-        <p:spPr>
-          <a:xfrm>
-            <a:off x="8686800" y="1097280"/>
-            <a:ext cx="1005840" cy="228600"/>
-          </a:xfrm>
-          <a:prstGeom prst="ellipse">
-            <a:avLst/>
-          </a:prstGeom>
-          <a:solidFill>
-            <a:srgbClr val="4F9CF9"/>
-          </a:solidFill>
-          <a:ln>
-            <a:noFill/>
-          </a:ln>
-        </p:spPr>
-        <p:style>
-          <a:lnRef idx="1">
-            <a:schemeClr val="accent1"/>
-          </a:lnRef>
-          <a:fillRef idx="3">
-            <a:schemeClr val="accent1"/>
-          </a:fillRef>
-          <a:effectRef idx="2">
-            <a:schemeClr val="accent1"/>
-          </a:effectRef>
-          <a:fontRef idx="minor">
-            <a:schemeClr val="lt1"/>
-          </a:fontRef>
-        </p:style>
-        <p:txBody>
-          <a:bodyPr rtlCol="0" anchor="ctr"/>
-          <a:lstStyle/>
-          <a:p>
-            <a:pPr algn="ctr"/>
-            <a:endParaRPr/>
-          </a:p>
-        </p:txBody>
-      </p:sp>
-      <p:sp>
-        <p:nvSpPr>
-          <p:cNvPr id="8" name="TextBox 7"/>
-          <p:cNvSpPr txBox="1"/>
-          <p:nvPr/>
-        </p:nvSpPr>
-        <p:spPr>
-          <a:xfrm>
-            <a:off x="7680960" y="3017520"/>
-            <a:ext cx="3017520" cy="1280160"/>
-          </a:xfrm>
-          <a:prstGeom prst="rect">
-            <a:avLst/>
-          </a:prstGeom>
-          <a:noFill/>
-        </p:spPr>
-        <p:txBody>
-          <a:bodyPr wrap="square">
-            <a:spAutoFit/>
-          </a:bodyPr>
-          <a:lstStyle/>
-          <a:p>
-            <a:pPr algn="ctr"/>
-            <a:r>
-              <a:rPr sz="1400" b="0">
-                <a:solidFill>
-                  <a:srgbClr val="7A9CC4"/>
-                </a:solidFill>
-              </a:rPr>
-              <a:t>📱
-วางภาพ screenshot
-ที่นี่</a:t>
-            </a:r>
-          </a:p>
-        </p:txBody>
-      </p:sp>
+            <a:endParaRPr lang="en-TH"/>
+          </a:p>
+        </p:txBody>
+      </p:sp>
+      <p:pic>
+        <p:nvPicPr>
+          <p:cNvPr id="11" name="Picture 10">
+            <a:extLst>
+              <a:ext uri="{FF2B5EF4-FFF2-40B4-BE49-F238E27FC236}">
+                <a16:creationId xmlns:a16="http://schemas.microsoft.com/office/drawing/2014/main" id="{4B8CE3D8-4438-BD01-4DDF-AD8EAABB3E2A}"/>
+              </a:ext>
+            </a:extLst>
+          </p:cNvPr>
+          <p:cNvPicPr>
+            <a:picLocks noChangeAspect="1"/>
+          </p:cNvPicPr>
+          <p:nvPr/>
+        </p:nvPicPr>
+        <p:blipFill>
+          <a:blip r:embed="rId3"/>
+          <a:stretch>
+            <a:fillRect/>
+          </a:stretch>
+        </p:blipFill>
+        <p:spPr>
+          <a:xfrm>
+            <a:off x="7589598" y="381918"/>
+            <a:ext cx="2848567" cy="6170364"/>
+          </a:xfrm>
+          <a:prstGeom prst="rect">
+            <a:avLst/>
+          </a:prstGeom>
+        </p:spPr>
+      </p:pic>
     </p:spTree>
   </p:cSld>
   <p:clrMapOvr>
@@ -19773,6 +19675,58 @@
       </p:grpSpPr>
       <p:sp>
         <p:nvSpPr>
+          <p:cNvPr id="12" name="Rectangle 11">
+            <a:extLst>
+              <a:ext uri="{FF2B5EF4-FFF2-40B4-BE49-F238E27FC236}">
+                <a16:creationId xmlns:a16="http://schemas.microsoft.com/office/drawing/2014/main" id="{ABEBE11B-4BBD-3318-426A-C869B68EEAC6}"/>
+              </a:ext>
+            </a:extLst>
+          </p:cNvPr>
+          <p:cNvSpPr/>
+          <p:nvPr/>
+        </p:nvSpPr>
+        <p:spPr>
+          <a:xfrm>
+            <a:off x="5838940" y="76200"/>
+            <a:ext cx="6349885" cy="6781800"/>
+          </a:xfrm>
+          <a:prstGeom prst="rect">
+            <a:avLst/>
+          </a:prstGeom>
+          <a:solidFill>
+            <a:schemeClr val="bg1"/>
+          </a:solidFill>
+          <a:ln>
+            <a:solidFill>
+              <a:schemeClr val="bg1"/>
+            </a:solidFill>
+          </a:ln>
+        </p:spPr>
+        <p:style>
+          <a:lnRef idx="1">
+            <a:schemeClr val="accent1"/>
+          </a:lnRef>
+          <a:fillRef idx="3">
+            <a:schemeClr val="accent1"/>
+          </a:fillRef>
+          <a:effectRef idx="2">
+            <a:schemeClr val="accent1"/>
+          </a:effectRef>
+          <a:fontRef idx="minor">
+            <a:schemeClr val="lt1"/>
+          </a:fontRef>
+        </p:style>
+        <p:txBody>
+          <a:bodyPr rtlCol="0" anchor="ctr"/>
+          <a:lstStyle/>
+          <a:p>
+            <a:pPr algn="ctr"/>
+            <a:endParaRPr lang="en-TH"/>
+          </a:p>
+        </p:txBody>
+      </p:sp>
+      <p:sp>
+        <p:nvSpPr>
           <p:cNvPr id="2" name="Rectangle 1"/>
           <p:cNvSpPr/>
           <p:nvPr/>
@@ -19996,132 +19950,36 @@
           </a:p>
         </p:txBody>
       </p:sp>
-      <p:sp>
-        <p:nvSpPr>
-          <p:cNvPr id="6" name="Rectangle 5"/>
-          <p:cNvSpPr/>
-          <p:nvPr/>
-        </p:nvSpPr>
-        <p:spPr>
-          <a:xfrm>
-            <a:off x="7589520" y="1005840"/>
-            <a:ext cx="3200400" cy="5394960"/>
-          </a:xfrm>
-          <a:prstGeom prst="rect">
-            <a:avLst/>
-          </a:prstGeom>
-          <a:solidFill>
-            <a:srgbClr val="0D1B2A"/>
-          </a:solidFill>
-          <a:ln w="31750">
-            <a:solidFill>
-              <a:srgbClr val="4F9CF9"/>
-            </a:solidFill>
-          </a:ln>
-        </p:spPr>
-        <p:style>
-          <a:lnRef idx="1">
-            <a:schemeClr val="accent1"/>
-          </a:lnRef>
-          <a:fillRef idx="3">
-            <a:schemeClr val="accent1"/>
-          </a:fillRef>
-          <a:effectRef idx="2">
-            <a:schemeClr val="accent1"/>
-          </a:effectRef>
-          <a:fontRef idx="minor">
-            <a:schemeClr val="lt1"/>
-          </a:fontRef>
-        </p:style>
-        <p:txBody>
-          <a:bodyPr rtlCol="0" anchor="ctr"/>
-          <a:lstStyle/>
-          <a:p>
-            <a:pPr algn="ctr"/>
-            <a:endParaRPr/>
-          </a:p>
-        </p:txBody>
-      </p:sp>
-      <p:sp>
-        <p:nvSpPr>
-          <p:cNvPr id="7" name="Oval 6"/>
-          <p:cNvSpPr/>
-          <p:nvPr/>
-        </p:nvSpPr>
-        <p:spPr>
-          <a:xfrm>
-            <a:off x="8686800" y="1097280"/>
-            <a:ext cx="1005840" cy="228600"/>
-          </a:xfrm>
-          <a:prstGeom prst="ellipse">
-            <a:avLst/>
-          </a:prstGeom>
-          <a:solidFill>
-            <a:srgbClr val="4F9CF9"/>
-          </a:solidFill>
-          <a:ln>
-            <a:noFill/>
-          </a:ln>
-        </p:spPr>
-        <p:style>
-          <a:lnRef idx="1">
-            <a:schemeClr val="accent1"/>
-          </a:lnRef>
-          <a:fillRef idx="3">
-            <a:schemeClr val="accent1"/>
-          </a:fillRef>
-          <a:effectRef idx="2">
-            <a:schemeClr val="accent1"/>
-          </a:effectRef>
-          <a:fontRef idx="minor">
-            <a:schemeClr val="lt1"/>
-          </a:fontRef>
-        </p:style>
-        <p:txBody>
-          <a:bodyPr rtlCol="0" anchor="ctr"/>
-          <a:lstStyle/>
-          <a:p>
-            <a:pPr algn="ctr"/>
-            <a:endParaRPr/>
-          </a:p>
-        </p:txBody>
-      </p:sp>
-      <p:sp>
-        <p:nvSpPr>
-          <p:cNvPr id="8" name="TextBox 7"/>
-          <p:cNvSpPr txBox="1"/>
-          <p:nvPr/>
-        </p:nvSpPr>
-        <p:spPr>
-          <a:xfrm>
-            <a:off x="7680960" y="3017520"/>
-            <a:ext cx="3017520" cy="1280160"/>
-          </a:xfrm>
-          <a:prstGeom prst="rect">
-            <a:avLst/>
-          </a:prstGeom>
-          <a:noFill/>
-        </p:spPr>
-        <p:txBody>
-          <a:bodyPr wrap="square">
-            <a:spAutoFit/>
-          </a:bodyPr>
-          <a:lstStyle/>
-          <a:p>
-            <a:pPr algn="ctr"/>
-            <a:r>
-              <a:rPr sz="1400" b="0">
-                <a:solidFill>
-                  <a:srgbClr val="7A9CC4"/>
-                </a:solidFill>
-              </a:rPr>
-              <a:t>📱
-วางภาพ screenshot
-ที่นี่</a:t>
-            </a:r>
-          </a:p>
-        </p:txBody>
-      </p:sp>
+      <p:pic>
+        <p:nvPicPr>
+          <p:cNvPr id="14" name="Picture 13">
+            <a:extLst>
+              <a:ext uri="{FF2B5EF4-FFF2-40B4-BE49-F238E27FC236}">
+                <a16:creationId xmlns:a16="http://schemas.microsoft.com/office/drawing/2014/main" id="{0D3B9B48-9DBC-905A-3239-5A9313C0DEBB}"/>
+              </a:ext>
+            </a:extLst>
+          </p:cNvPr>
+          <p:cNvPicPr>
+            <a:picLocks noChangeAspect="1"/>
+          </p:cNvPicPr>
+          <p:nvPr/>
+        </p:nvPicPr>
+        <p:blipFill>
+          <a:blip r:embed="rId3"/>
+          <a:stretch>
+            <a:fillRect/>
+          </a:stretch>
+        </p:blipFill>
+        <p:spPr>
+          <a:xfrm>
+            <a:off x="7476775" y="152400"/>
+            <a:ext cx="3074214" cy="6659146"/>
+          </a:xfrm>
+          <a:prstGeom prst="rect">
+            <a:avLst/>
+          </a:prstGeom>
+        </p:spPr>
+      </p:pic>
     </p:spTree>
   </p:cSld>
   <p:clrMapOvr>

</xml_diff>